<commit_message>
Update PPT giga.pptx (template)
Made-with: Cursor
</commit_message>
<xml_diff>
--- a/PPT giga.pptx
+++ b/PPT giga.pptx
@@ -3891,7 +3891,7 @@
               <a:buNone/>
             </a:pPr>
             <a:r>
-              <a:rPr lang="en-US" sz="1710" b="1" kern="0" spc="-34" dirty="0">
+              <a:rPr lang="en-US" sz="1710" kern="0" spc="-34" dirty="0">
                 <a:solidFill>
                   <a:srgbClr val="000000">
                     <a:alpha val="99000"/>
@@ -4078,7 +4078,7 @@
       </p:sp>
       <p:pic>
         <p:nvPicPr>
-          <p:cNvPr id="4" name="Image 0" descr="preencoded.png"/>
+          <p:cNvPr id="8" name="Image 4" descr="preencoded.png"/>
           <p:cNvPicPr>
             <a:picLocks noChangeAspect="1"/>
           </p:cNvPicPr>
@@ -4086,106 +4086,6 @@
         </p:nvPicPr>
         <p:blipFill>
           <a:blip r:embed="rId3"/>
-          <a:srcRect r="50492" b="64906"/>
-          <a:stretch>
-            <a:fillRect/>
-          </a:stretch>
-        </p:blipFill>
-        <p:spPr>
-          <a:xfrm>
-            <a:off x="476250" y="1443410"/>
-            <a:ext cx="950214" cy="885825"/>
-          </a:xfrm>
-          <a:prstGeom prst="rect">
-            <a:avLst/>
-          </a:prstGeom>
-        </p:spPr>
-      </p:pic>
-      <p:pic>
-        <p:nvPicPr>
-          <p:cNvPr id="5" name="Image 1" descr="preencoded.png"/>
-          <p:cNvPicPr>
-            <a:picLocks noChangeAspect="1"/>
-          </p:cNvPicPr>
-          <p:nvPr/>
-        </p:nvPicPr>
-        <p:blipFill rotWithShape="1">
-          <a:blip r:embed="rId4"/>
-          <a:srcRect l="2162" t="3570" r="52723" b="64905"/>
-          <a:stretch>
-            <a:fillRect/>
-          </a:stretch>
-        </p:blipFill>
-        <p:spPr>
-          <a:xfrm>
-            <a:off x="2608480" y="1600200"/>
-            <a:ext cx="865881" cy="795718"/>
-          </a:xfrm>
-          <a:prstGeom prst="rect">
-            <a:avLst/>
-          </a:prstGeom>
-        </p:spPr>
-      </p:pic>
-      <p:pic>
-        <p:nvPicPr>
-          <p:cNvPr id="6" name="Image 2" descr="preencoded.png"/>
-          <p:cNvPicPr>
-            <a:picLocks noChangeAspect="1"/>
-          </p:cNvPicPr>
-          <p:nvPr/>
-        </p:nvPicPr>
-        <p:blipFill>
-          <a:blip r:embed="rId5"/>
-          <a:srcRect r="48725" b="64906"/>
-          <a:stretch>
-            <a:fillRect/>
-          </a:stretch>
-        </p:blipFill>
-        <p:spPr>
-          <a:xfrm>
-            <a:off x="4657725" y="1527239"/>
-            <a:ext cx="984123" cy="885825"/>
-          </a:xfrm>
-          <a:prstGeom prst="rect">
-            <a:avLst/>
-          </a:prstGeom>
-        </p:spPr>
-      </p:pic>
-      <p:pic>
-        <p:nvPicPr>
-          <p:cNvPr id="7" name="Image 3" descr="preencoded.png"/>
-          <p:cNvPicPr>
-            <a:picLocks noChangeAspect="1"/>
-          </p:cNvPicPr>
-          <p:nvPr/>
-        </p:nvPicPr>
-        <p:blipFill>
-          <a:blip r:embed="rId6"/>
-          <a:srcRect r="49032" b="64906"/>
-          <a:stretch>
-            <a:fillRect/>
-          </a:stretch>
-        </p:blipFill>
-        <p:spPr>
-          <a:xfrm>
-            <a:off x="6748463" y="1499616"/>
-            <a:ext cx="978217" cy="885825"/>
-          </a:xfrm>
-          <a:prstGeom prst="rect">
-            <a:avLst/>
-          </a:prstGeom>
-        </p:spPr>
-      </p:pic>
-      <p:pic>
-        <p:nvPicPr>
-          <p:cNvPr id="8" name="Image 4" descr="preencoded.png"/>
-          <p:cNvPicPr>
-            <a:picLocks noChangeAspect="1"/>
-          </p:cNvPicPr>
-          <p:nvPr/>
-        </p:nvPicPr>
-        <p:blipFill>
-          <a:blip r:embed="rId7"/>
           <a:srcRect/>
           <a:stretch/>
         </p:blipFill>
@@ -5090,11 +4990,167 @@
           </a:p>
         </p:txBody>
       </p:sp>
+      <p:pic>
+        <p:nvPicPr>
+          <p:cNvPr id="26" name="Graphic 25">
+            <a:extLst>
+              <a:ext uri="{FF2B5EF4-FFF2-40B4-BE49-F238E27FC236}">
+                <a16:creationId xmlns:a16="http://schemas.microsoft.com/office/drawing/2014/main" id="{7C155289-BB85-548D-302C-75C533B1CA58}"/>
+              </a:ext>
+            </a:extLst>
+          </p:cNvPr>
+          <p:cNvPicPr>
+            <a:picLocks noChangeAspect="1"/>
+          </p:cNvPicPr>
+          <p:nvPr/>
+        </p:nvPicPr>
+        <p:blipFill>
+          <a:blip r:embed="rId4">
+            <a:extLst>
+              <a:ext uri="{96DAC541-7B7A-43D3-8B79-37D633B846F1}">
+                <asvg:svgBlip xmlns:asvg="http://schemas.microsoft.com/office/drawing/2016/SVG/main" r:embed="rId5"/>
+              </a:ext>
+            </a:extLst>
+          </a:blip>
+          <a:stretch>
+            <a:fillRect/>
+          </a:stretch>
+        </p:blipFill>
+        <p:spPr>
+          <a:xfrm>
+            <a:off x="669750" y="1640260"/>
+            <a:ext cx="582978" cy="586839"/>
+          </a:xfrm>
+          <a:prstGeom prst="rect">
+            <a:avLst/>
+          </a:prstGeom>
+        </p:spPr>
+      </p:pic>
+      <p:pic>
+        <p:nvPicPr>
+          <p:cNvPr id="37" name="Graphic 36">
+            <a:extLst>
+              <a:ext uri="{FF2B5EF4-FFF2-40B4-BE49-F238E27FC236}">
+                <a16:creationId xmlns:a16="http://schemas.microsoft.com/office/drawing/2014/main" id="{132D71BF-906D-3314-E860-B86ADCECEC6B}"/>
+              </a:ext>
+            </a:extLst>
+          </p:cNvPr>
+          <p:cNvPicPr>
+            <a:picLocks noChangeAspect="1"/>
+          </p:cNvPicPr>
+          <p:nvPr/>
+        </p:nvPicPr>
+        <p:blipFill>
+          <a:blip r:embed="rId6">
+            <a:extLst>
+              <a:ext uri="{96DAC541-7B7A-43D3-8B79-37D633B846F1}">
+                <asvg:svgBlip xmlns:asvg="http://schemas.microsoft.com/office/drawing/2016/SVG/main" r:embed="rId7"/>
+              </a:ext>
+            </a:extLst>
+          </a:blip>
+          <a:stretch>
+            <a:fillRect/>
+          </a:stretch>
+        </p:blipFill>
+        <p:spPr>
+          <a:xfrm>
+            <a:off x="2762662" y="1704385"/>
+            <a:ext cx="581616" cy="581616"/>
+          </a:xfrm>
+          <a:prstGeom prst="rect">
+            <a:avLst/>
+          </a:prstGeom>
+        </p:spPr>
+      </p:pic>
+      <p:pic>
+        <p:nvPicPr>
+          <p:cNvPr id="40" name="Graphic 39">
+            <a:extLst>
+              <a:ext uri="{FF2B5EF4-FFF2-40B4-BE49-F238E27FC236}">
+                <a16:creationId xmlns:a16="http://schemas.microsoft.com/office/drawing/2014/main" id="{CE182398-52D7-A37A-2427-5FF82A0E60C0}"/>
+              </a:ext>
+            </a:extLst>
+          </p:cNvPr>
+          <p:cNvPicPr>
+            <a:picLocks noChangeAspect="1"/>
+          </p:cNvPicPr>
+          <p:nvPr/>
+        </p:nvPicPr>
+        <p:blipFill>
+          <a:blip r:embed="rId8">
+            <a:extLst>
+              <a:ext uri="{96DAC541-7B7A-43D3-8B79-37D633B846F1}">
+                <asvg:svgBlip xmlns:asvg="http://schemas.microsoft.com/office/drawing/2016/SVG/main" r:embed="rId9"/>
+              </a:ext>
+            </a:extLst>
+          </a:blip>
+          <a:stretch>
+            <a:fillRect/>
+          </a:stretch>
+        </p:blipFill>
+        <p:spPr>
+          <a:xfrm>
+            <a:off x="4863355" y="1741619"/>
+            <a:ext cx="570848" cy="574628"/>
+          </a:xfrm>
+          <a:prstGeom prst="rect">
+            <a:avLst/>
+          </a:prstGeom>
+        </p:spPr>
+      </p:pic>
+      <p:pic>
+        <p:nvPicPr>
+          <p:cNvPr id="43" name="Graphic 42">
+            <a:extLst>
+              <a:ext uri="{FF2B5EF4-FFF2-40B4-BE49-F238E27FC236}">
+                <a16:creationId xmlns:a16="http://schemas.microsoft.com/office/drawing/2014/main" id="{82E34B89-98C4-8E6F-0F4A-9B5F8C9C492F}"/>
+              </a:ext>
+            </a:extLst>
+          </p:cNvPr>
+          <p:cNvPicPr>
+            <a:picLocks noChangeAspect="1"/>
+          </p:cNvPicPr>
+          <p:nvPr/>
+        </p:nvPicPr>
+        <p:blipFill>
+          <a:blip r:embed="rId10">
+            <a:extLst>
+              <a:ext uri="{96DAC541-7B7A-43D3-8B79-37D633B846F1}">
+                <asvg:svgBlip xmlns:asvg="http://schemas.microsoft.com/office/drawing/2016/SVG/main" r:embed="rId11"/>
+              </a:ext>
+            </a:extLst>
+          </a:blip>
+          <a:stretch>
+            <a:fillRect/>
+          </a:stretch>
+        </p:blipFill>
+        <p:spPr>
+          <a:xfrm>
+            <a:off x="6939222" y="1700281"/>
+            <a:ext cx="585719" cy="585719"/>
+          </a:xfrm>
+          <a:prstGeom prst="rect">
+            <a:avLst/>
+          </a:prstGeom>
+        </p:spPr>
+      </p:pic>
     </p:spTree>
   </p:cSld>
   <p:clrMapOvr>
     <a:masterClrMapping/>
   </p:clrMapOvr>
+  <mc:AlternateContent xmlns:mc="http://schemas.openxmlformats.org/markup-compatibility/2006">
+    <mc:Choice xmlns:p14="http://schemas.microsoft.com/office/powerpoint/2010/main" Requires="p14">
+      <p:transition spd="med" p14:dur="700">
+        <p:fade/>
+      </p:transition>
+    </mc:Choice>
+    <mc:Fallback>
+      <p:transition spd="med">
+        <p:fade/>
+      </p:transition>
+    </mc:Fallback>
+  </mc:AlternateContent>
 </p:sld>
 </file>
 
@@ -5166,7 +5222,9 @@
           <a:ln/>
         </p:spPr>
         <p:txBody>
-          <a:bodyPr wrap="square" lIns="0" tIns="0" rIns="0" bIns="0" rtlCol="0" anchor="ctr"/>
+          <a:bodyPr wrap="square" lIns="0" tIns="0" rIns="0" bIns="0" rtlCol="0" anchor="t">
+            <a:normAutofit/>
+          </a:bodyPr>
           <a:lstStyle/>
           <a:p>
             <a:pPr marL="0" indent="0" algn="l">
@@ -5210,7 +5268,9 @@
           <a:ln/>
         </p:spPr>
         <p:txBody>
-          <a:bodyPr wrap="square" lIns="0" tIns="0" rIns="0" bIns="0" rtlCol="0" anchor="t"/>
+          <a:bodyPr wrap="square" lIns="0" tIns="0" rIns="0" bIns="0" rtlCol="0" anchor="t">
+            <a:normAutofit/>
+          </a:bodyPr>
           <a:lstStyle/>
           <a:p>
             <a:pPr marL="0" indent="0" algn="l">
@@ -5279,7 +5339,9 @@
           <a:ln/>
         </p:spPr>
         <p:txBody>
-          <a:bodyPr wrap="square" lIns="0" tIns="0" rIns="0" bIns="0" rtlCol="0" anchor="ctr"/>
+          <a:bodyPr wrap="square" lIns="0" tIns="0" rIns="0" bIns="0" rtlCol="0" anchor="t">
+            <a:normAutofit/>
+          </a:bodyPr>
           <a:lstStyle/>
           <a:p>
             <a:pPr marL="0" indent="0" algn="l">
@@ -5323,7 +5385,9 @@
           <a:ln/>
         </p:spPr>
         <p:txBody>
-          <a:bodyPr wrap="square" lIns="0" tIns="0" rIns="0" bIns="0" rtlCol="0" anchor="t"/>
+          <a:bodyPr wrap="square" lIns="0" tIns="0" rIns="0" bIns="0" rtlCol="0" anchor="t">
+            <a:normAutofit/>
+          </a:bodyPr>
           <a:lstStyle/>
           <a:p>
             <a:pPr marL="0" indent="0" algn="l">
@@ -5392,7 +5456,9 @@
           <a:ln/>
         </p:spPr>
         <p:txBody>
-          <a:bodyPr wrap="square" lIns="0" tIns="0" rIns="0" bIns="0" rtlCol="0" anchor="ctr"/>
+          <a:bodyPr wrap="square" lIns="0" tIns="0" rIns="0" bIns="0" rtlCol="0" anchor="t">
+            <a:normAutofit/>
+          </a:bodyPr>
           <a:lstStyle/>
           <a:p>
             <a:pPr marL="0" indent="0" algn="l">
@@ -5436,7 +5502,9 @@
           <a:ln/>
         </p:spPr>
         <p:txBody>
-          <a:bodyPr wrap="square" lIns="0" tIns="0" rIns="0" bIns="0" rtlCol="0" anchor="t"/>
+          <a:bodyPr wrap="square" lIns="0" tIns="0" rIns="0" bIns="0" rtlCol="0" anchor="t">
+            <a:normAutofit/>
+          </a:bodyPr>
           <a:lstStyle/>
           <a:p>
             <a:pPr marL="0" indent="0" algn="l">
@@ -5505,7 +5573,9 @@
           <a:ln/>
         </p:spPr>
         <p:txBody>
-          <a:bodyPr wrap="square" lIns="0" tIns="0" rIns="0" bIns="0" rtlCol="0" anchor="ctr"/>
+          <a:bodyPr wrap="square" lIns="0" tIns="0" rIns="0" bIns="0" rtlCol="0" anchor="t">
+            <a:normAutofit/>
+          </a:bodyPr>
           <a:lstStyle/>
           <a:p>
             <a:pPr marL="0" indent="0" algn="l">
@@ -5549,7 +5619,9 @@
           <a:ln/>
         </p:spPr>
         <p:txBody>
-          <a:bodyPr wrap="square" lIns="0" tIns="0" rIns="0" bIns="0" rtlCol="0" anchor="t"/>
+          <a:bodyPr wrap="square" lIns="0" tIns="0" rIns="0" bIns="0" rtlCol="0" anchor="t">
+            <a:normAutofit/>
+          </a:bodyPr>
           <a:lstStyle/>
           <a:p>
             <a:pPr marL="0" indent="0" algn="l">
@@ -5618,7 +5690,9 @@
           <a:ln/>
         </p:spPr>
         <p:txBody>
-          <a:bodyPr wrap="square" lIns="0" tIns="0" rIns="0" bIns="0" rtlCol="0" anchor="ctr"/>
+          <a:bodyPr wrap="square" lIns="0" tIns="0" rIns="0" bIns="0" rtlCol="0" anchor="t">
+            <a:normAutofit/>
+          </a:bodyPr>
           <a:lstStyle/>
           <a:p>
             <a:pPr marL="0" indent="0" algn="l">
@@ -5662,7 +5736,9 @@
           <a:ln/>
         </p:spPr>
         <p:txBody>
-          <a:bodyPr wrap="square" lIns="0" tIns="0" rIns="0" bIns="0" rtlCol="0" anchor="t"/>
+          <a:bodyPr wrap="square" lIns="0" tIns="0" rIns="0" bIns="0" rtlCol="0" anchor="t">
+            <a:normAutofit/>
+          </a:bodyPr>
           <a:lstStyle/>
           <a:p>
             <a:pPr marL="0" indent="0" algn="l">
@@ -5731,7 +5807,9 @@
           <a:ln/>
         </p:spPr>
         <p:txBody>
-          <a:bodyPr wrap="square" lIns="0" tIns="0" rIns="0" bIns="0" rtlCol="0" anchor="ctr"/>
+          <a:bodyPr wrap="square" lIns="0" tIns="0" rIns="0" bIns="0" rtlCol="0" anchor="t">
+            <a:normAutofit/>
+          </a:bodyPr>
           <a:lstStyle/>
           <a:p>
             <a:pPr marL="0" indent="0" algn="l">
@@ -5775,7 +5853,9 @@
           <a:ln/>
         </p:spPr>
         <p:txBody>
-          <a:bodyPr wrap="square" lIns="0" tIns="0" rIns="0" bIns="0" rtlCol="0" anchor="t"/>
+          <a:bodyPr wrap="square" lIns="0" tIns="0" rIns="0" bIns="0" rtlCol="0" anchor="t">
+            <a:normAutofit/>
+          </a:bodyPr>
           <a:lstStyle/>
           <a:p>
             <a:pPr marL="0" indent="0" algn="l">
@@ -5810,7 +5890,7 @@
         <p:spPr>
           <a:xfrm>
             <a:off x="476250" y="476250"/>
-            <a:ext cx="3404374" cy="1257300"/>
+            <a:ext cx="3404374" cy="3467100"/>
           </a:xfrm>
           <a:prstGeom prst="rect">
             <a:avLst/>
@@ -5819,7 +5899,7 @@
           <a:ln/>
         </p:spPr>
         <p:txBody>
-          <a:bodyPr wrap="square" lIns="0" tIns="0" rIns="0" bIns="0" rtlCol="0" anchor="ctr"/>
+          <a:bodyPr wrap="square" lIns="0" tIns="0" rIns="0" bIns="0" rtlCol="0" anchor="t"/>
           <a:lstStyle/>
           <a:p>
             <a:pPr marL="0" indent="0" algn="l">
@@ -5939,6 +6019,18 @@
   <p:clrMapOvr>
     <a:masterClrMapping/>
   </p:clrMapOvr>
+  <mc:AlternateContent xmlns:mc="http://schemas.openxmlformats.org/markup-compatibility/2006">
+    <mc:Choice xmlns:p14="http://schemas.microsoft.com/office/powerpoint/2010/main" Requires="p14">
+      <p:transition spd="med" p14:dur="700">
+        <p:fade/>
+      </p:transition>
+    </mc:Choice>
+    <mc:Fallback>
+      <p:transition spd="med">
+        <p:fade/>
+      </p:transition>
+    </mc:Fallback>
+  </mc:AlternateContent>
 </p:sld>
 </file>
 
@@ -5975,8 +6067,8 @@
         </p:nvSpPr>
         <p:spPr>
           <a:xfrm>
-            <a:off x="476250" y="476250"/>
-            <a:ext cx="3162300" cy="1257300"/>
+            <a:off x="476250" y="476249"/>
+            <a:ext cx="3162300" cy="2879271"/>
           </a:xfrm>
           <a:prstGeom prst="rect">
             <a:avLst/>
@@ -5985,7 +6077,7 @@
           <a:ln/>
         </p:spPr>
         <p:txBody>
-          <a:bodyPr wrap="square" lIns="0" tIns="0" rIns="0" bIns="0" rtlCol="0" anchor="ctr"/>
+          <a:bodyPr wrap="square" lIns="0" tIns="0" rIns="0" bIns="0" rtlCol="0" anchor="t"/>
           <a:lstStyle/>
           <a:p>
             <a:pPr marL="0" indent="0" algn="l">
@@ -6118,7 +6210,7 @@
           <a:ln/>
         </p:spPr>
         <p:txBody>
-          <a:bodyPr wrap="square" lIns="0" tIns="0" rIns="0" bIns="0" rtlCol="0" anchor="ctr"/>
+          <a:bodyPr wrap="square" lIns="0" tIns="0" rIns="0" bIns="0" rtlCol="0" anchor="t"/>
           <a:lstStyle/>
           <a:p>
             <a:pPr marL="0" indent="0" algn="l">
@@ -6162,7 +6254,7 @@
           <a:ln/>
         </p:spPr>
         <p:txBody>
-          <a:bodyPr wrap="square" lIns="0" tIns="0" rIns="0" bIns="0" rtlCol="0" anchor="ctr"/>
+          <a:bodyPr wrap="square" lIns="0" tIns="0" rIns="0" bIns="0" rtlCol="0" anchor="t"/>
           <a:lstStyle/>
           <a:p>
             <a:pPr marL="0" indent="0" algn="l">
@@ -6196,8 +6288,8 @@
         </p:nvSpPr>
         <p:spPr>
           <a:xfrm>
-            <a:off x="6096000" y="2090738"/>
-            <a:ext cx="2657475" cy="914400"/>
+            <a:off x="6096000" y="2090737"/>
+            <a:ext cx="2657475" cy="1705655"/>
           </a:xfrm>
           <a:prstGeom prst="rect">
             <a:avLst/>
@@ -6206,7 +6298,7 @@
           <a:ln/>
         </p:spPr>
         <p:txBody>
-          <a:bodyPr wrap="square" lIns="0" tIns="0" rIns="0" bIns="0" rtlCol="0" anchor="ctr"/>
+          <a:bodyPr wrap="square" lIns="0" tIns="0" rIns="0" bIns="0" rtlCol="0" anchor="t"/>
           <a:lstStyle/>
           <a:p>
             <a:pPr marL="0" indent="0" algn="l">
@@ -6240,8 +6332,8 @@
         </p:nvSpPr>
         <p:spPr>
           <a:xfrm>
-            <a:off x="6096000" y="476250"/>
-            <a:ext cx="2657475" cy="914400"/>
+            <a:off x="6096000" y="476249"/>
+            <a:ext cx="2657475" cy="1450521"/>
           </a:xfrm>
           <a:prstGeom prst="rect">
             <a:avLst/>
@@ -6250,7 +6342,7 @@
           <a:ln/>
         </p:spPr>
         <p:txBody>
-          <a:bodyPr wrap="square" lIns="0" tIns="0" rIns="0" bIns="0" rtlCol="0" anchor="ctr"/>
+          <a:bodyPr wrap="square" lIns="0" tIns="0" rIns="0" bIns="0" rtlCol="0" anchor="t"/>
           <a:lstStyle/>
           <a:p>
             <a:pPr marL="0" indent="0" algn="l">
@@ -6281,6 +6373,18 @@
   <p:clrMapOvr>
     <a:masterClrMapping/>
   </p:clrMapOvr>
+  <mc:AlternateContent xmlns:mc="http://schemas.openxmlformats.org/markup-compatibility/2006">
+    <mc:Choice xmlns:p14="http://schemas.microsoft.com/office/powerpoint/2010/main" Requires="p14">
+      <p:transition spd="med" p14:dur="700">
+        <p:fade/>
+      </p:transition>
+    </mc:Choice>
+    <mc:Fallback>
+      <p:transition spd="med">
+        <p:fade/>
+      </p:transition>
+    </mc:Fallback>
+  </mc:AlternateContent>
 </p:sld>
 </file>
 
@@ -6384,8 +6488,8 @@
         </p:nvSpPr>
         <p:spPr>
           <a:xfrm>
-            <a:off x="485775" y="476250"/>
-            <a:ext cx="4176712" cy="1727454"/>
+            <a:off x="485775" y="476249"/>
+            <a:ext cx="3057525" cy="3099707"/>
           </a:xfrm>
           <a:prstGeom prst="rect">
             <a:avLst/>
@@ -6453,6 +6557,18 @@
   <p:clrMapOvr>
     <a:masterClrMapping/>
   </p:clrMapOvr>
+  <mc:AlternateContent xmlns:mc="http://schemas.openxmlformats.org/markup-compatibility/2006">
+    <mc:Choice xmlns:p14="http://schemas.microsoft.com/office/powerpoint/2010/main" Requires="p14">
+      <p:transition spd="med" p14:dur="700">
+        <p:fade/>
+      </p:transition>
+    </mc:Choice>
+    <mc:Fallback>
+      <p:transition spd="med">
+        <p:fade/>
+      </p:transition>
+    </mc:Fallback>
+  </mc:AlternateContent>
 </p:sld>
 </file>
 
@@ -6557,7 +6673,7 @@
         <p:spPr>
           <a:xfrm>
             <a:off x="485775" y="476250"/>
-            <a:ext cx="4176712" cy="838200"/>
+            <a:ext cx="3147332" cy="2895600"/>
           </a:xfrm>
           <a:prstGeom prst="rect">
             <a:avLst/>
@@ -6566,7 +6682,7 @@
           <a:ln/>
         </p:spPr>
         <p:txBody>
-          <a:bodyPr wrap="square" lIns="0" tIns="0" rIns="0" bIns="0" rtlCol="0" anchor="ctr"/>
+          <a:bodyPr wrap="square" lIns="0" tIns="0" rIns="0" bIns="0" rtlCol="0" anchor="t"/>
           <a:lstStyle/>
           <a:p>
             <a:pPr marL="0" indent="0" algn="l">
@@ -6592,8 +6708,8 @@
           </a:p>
         </p:txBody>
       </p:sp>
-      <mc:AlternateContent xmlns:mc="http://schemas.openxmlformats.org/markup-compatibility/2006">
-        <mc:Choice xmlns:cx1="http://schemas.microsoft.com/office/drawing/2015/9/8/chartex" Requires="cx1">
+      <mc:AlternateContent xmlns:mc="http://schemas.openxmlformats.org/markup-compatibility/2006" xmlns:cx1="http://schemas.microsoft.com/office/drawing/2015/9/8/chartex">
+        <mc:Choice Requires="cx1">
           <p:graphicFrame>
             <p:nvGraphicFramePr>
               <p:cNvPr id="32" name="Chart 31">
@@ -6623,7 +6739,7 @@
             </a:graphic>
           </p:graphicFrame>
         </mc:Choice>
-        <mc:Fallback>
+        <mc:Fallback xmlns="">
           <p:pic>
             <p:nvPicPr>
               <p:cNvPr id="32" name="Chart 31">
@@ -6661,6 +6777,18 @@
   <p:clrMapOvr>
     <a:masterClrMapping/>
   </p:clrMapOvr>
+  <mc:AlternateContent xmlns:mc="http://schemas.openxmlformats.org/markup-compatibility/2006">
+    <mc:Choice xmlns:p14="http://schemas.microsoft.com/office/powerpoint/2010/main" Requires="p14">
+      <p:transition spd="med" p14:dur="700">
+        <p:fade/>
+      </p:transition>
+    </mc:Choice>
+    <mc:Fallback>
+      <p:transition spd="med">
+        <p:fade/>
+      </p:transition>
+    </mc:Fallback>
+  </mc:AlternateContent>
 </p:sld>
 </file>
 
@@ -6698,7 +6826,7 @@
         <p:spPr>
           <a:xfrm>
             <a:off x="476250" y="476250"/>
-            <a:ext cx="3171825" cy="419100"/>
+            <a:ext cx="3843337" cy="1333500"/>
           </a:xfrm>
           <a:prstGeom prst="rect">
             <a:avLst/>
@@ -6707,7 +6835,7 @@
           <a:ln/>
         </p:spPr>
         <p:txBody>
-          <a:bodyPr wrap="square" lIns="0" tIns="0" rIns="0" bIns="0" rtlCol="0" anchor="ctr"/>
+          <a:bodyPr wrap="square" lIns="0" tIns="0" rIns="0" bIns="0" rtlCol="0" anchor="t"/>
           <a:lstStyle/>
           <a:p>
             <a:pPr marL="0" indent="0" algn="l">
@@ -6808,8 +6936,8 @@
         </p:nvSpPr>
         <p:spPr>
           <a:xfrm>
-            <a:off x="504825" y="3068442"/>
-            <a:ext cx="681038" cy="247650"/>
+            <a:off x="504824" y="3011294"/>
+            <a:ext cx="1876425" cy="247650"/>
           </a:xfrm>
           <a:prstGeom prst="rect">
             <a:avLst/>
@@ -6852,8 +6980,8 @@
         </p:nvSpPr>
         <p:spPr>
           <a:xfrm>
-            <a:off x="495300" y="3276600"/>
-            <a:ext cx="1885950" cy="566738"/>
+            <a:off x="495300" y="3333751"/>
+            <a:ext cx="1885950" cy="657225"/>
           </a:xfrm>
           <a:prstGeom prst="rect">
             <a:avLst/>
@@ -6862,7 +6990,7 @@
           <a:ln/>
         </p:spPr>
         <p:txBody>
-          <a:bodyPr wrap="square" lIns="0" tIns="0" rIns="0" bIns="0" rtlCol="0" anchor="ctr"/>
+          <a:bodyPr wrap="square" lIns="0" tIns="0" rIns="0" bIns="0" rtlCol="0" anchor="t"/>
           <a:lstStyle/>
           <a:p>
             <a:pPr marL="0" indent="0" algn="l">
@@ -6896,8 +7024,8 @@
         </p:nvSpPr>
         <p:spPr>
           <a:xfrm>
-            <a:off x="2652713" y="3082730"/>
-            <a:ext cx="595313" cy="247650"/>
+            <a:off x="2652713" y="3025582"/>
+            <a:ext cx="1814513" cy="247650"/>
           </a:xfrm>
           <a:prstGeom prst="rect">
             <a:avLst/>
@@ -6940,8 +7068,8 @@
         </p:nvSpPr>
         <p:spPr>
           <a:xfrm>
-            <a:off x="2652713" y="3290888"/>
-            <a:ext cx="1814513" cy="566738"/>
+            <a:off x="2652713" y="3348039"/>
+            <a:ext cx="1814513" cy="657225"/>
           </a:xfrm>
           <a:prstGeom prst="rect">
             <a:avLst/>
@@ -6950,7 +7078,7 @@
           <a:ln/>
         </p:spPr>
         <p:txBody>
-          <a:bodyPr wrap="square" lIns="0" tIns="0" rIns="0" bIns="0" rtlCol="0" anchor="ctr"/>
+          <a:bodyPr wrap="square" lIns="0" tIns="0" rIns="0" bIns="0" rtlCol="0" anchor="t"/>
           <a:lstStyle/>
           <a:p>
             <a:pPr marL="0" indent="0" algn="l">
@@ -6984,8 +7112,8 @@
         </p:nvSpPr>
         <p:spPr>
           <a:xfrm>
-            <a:off x="4819650" y="1044379"/>
-            <a:ext cx="676275" cy="247650"/>
+            <a:off x="4819650" y="987231"/>
+            <a:ext cx="1666875" cy="247650"/>
           </a:xfrm>
           <a:prstGeom prst="rect">
             <a:avLst/>
@@ -7028,8 +7156,8 @@
         </p:nvSpPr>
         <p:spPr>
           <a:xfrm>
-            <a:off x="4819650" y="1252538"/>
-            <a:ext cx="1666875" cy="566738"/>
+            <a:off x="4819650" y="1309689"/>
+            <a:ext cx="1666875" cy="657225"/>
           </a:xfrm>
           <a:prstGeom prst="rect">
             <a:avLst/>
@@ -7038,7 +7166,7 @@
           <a:ln/>
         </p:spPr>
         <p:txBody>
-          <a:bodyPr wrap="square" lIns="0" tIns="0" rIns="0" bIns="0" rtlCol="0" anchor="ctr"/>
+          <a:bodyPr wrap="square" lIns="0" tIns="0" rIns="0" bIns="0" rtlCol="0" anchor="t"/>
           <a:lstStyle/>
           <a:p>
             <a:pPr marL="0" indent="0" algn="l">
@@ -7072,8 +7200,8 @@
         </p:nvSpPr>
         <p:spPr>
           <a:xfrm>
-            <a:off x="6986588" y="1044379"/>
-            <a:ext cx="666750" cy="247650"/>
+            <a:off x="6986588" y="987231"/>
+            <a:ext cx="1666874" cy="247650"/>
           </a:xfrm>
           <a:prstGeom prst="rect">
             <a:avLst/>
@@ -7116,8 +7244,8 @@
         </p:nvSpPr>
         <p:spPr>
           <a:xfrm>
-            <a:off x="6986588" y="1252538"/>
-            <a:ext cx="1704975" cy="566738"/>
+            <a:off x="6986588" y="1309689"/>
+            <a:ext cx="1704975" cy="657225"/>
           </a:xfrm>
           <a:prstGeom prst="rect">
             <a:avLst/>
@@ -7126,7 +7254,7 @@
           <a:ln/>
         </p:spPr>
         <p:txBody>
-          <a:bodyPr wrap="square" lIns="0" tIns="0" rIns="0" bIns="0" rtlCol="0" anchor="ctr"/>
+          <a:bodyPr wrap="square" lIns="0" tIns="0" rIns="0" bIns="0" rtlCol="0" anchor="t"/>
           <a:lstStyle/>
           <a:p>
             <a:pPr marL="0" indent="0" algn="l">
@@ -7296,6 +7424,18 @@
   <p:clrMapOvr>
     <a:masterClrMapping/>
   </p:clrMapOvr>
+  <mc:AlternateContent xmlns:mc="http://schemas.openxmlformats.org/markup-compatibility/2006">
+    <mc:Choice xmlns:p14="http://schemas.microsoft.com/office/powerpoint/2010/main" Requires="p14">
+      <p:transition spd="med" p14:dur="700">
+        <p:fade/>
+      </p:transition>
+    </mc:Choice>
+    <mc:Fallback>
+      <p:transition spd="med">
+        <p:fade/>
+      </p:transition>
+    </mc:Fallback>
+  </mc:AlternateContent>
 </p:sld>
 </file>
 
@@ -7611,8 +7751,8 @@
         </p:nvSpPr>
         <p:spPr>
           <a:xfrm>
-            <a:off x="514350" y="3067050"/>
-            <a:ext cx="681038" cy="247650"/>
+            <a:off x="514349" y="2993572"/>
+            <a:ext cx="1386057" cy="247650"/>
           </a:xfrm>
           <a:prstGeom prst="rect">
             <a:avLst/>
@@ -7655,8 +7795,8 @@
         </p:nvSpPr>
         <p:spPr>
           <a:xfrm>
-            <a:off x="504825" y="3371850"/>
-            <a:ext cx="1376363" cy="566738"/>
+            <a:off x="504825" y="3298372"/>
+            <a:ext cx="1376363" cy="736826"/>
           </a:xfrm>
           <a:prstGeom prst="rect">
             <a:avLst/>
@@ -7665,7 +7805,7 @@
           <a:ln/>
         </p:spPr>
         <p:txBody>
-          <a:bodyPr wrap="square" lIns="0" tIns="0" rIns="0" bIns="0" rtlCol="0" anchor="ctr"/>
+          <a:bodyPr wrap="square" lIns="0" tIns="0" rIns="0" bIns="0" rtlCol="0" anchor="t"/>
           <a:lstStyle/>
           <a:p>
             <a:pPr marL="0" indent="0" algn="l">
@@ -7699,8 +7839,8 @@
         </p:nvSpPr>
         <p:spPr>
           <a:xfrm>
-            <a:off x="2224088" y="3067050"/>
-            <a:ext cx="595313" cy="247650"/>
+            <a:off x="2224088" y="2993572"/>
+            <a:ext cx="1211588" cy="247650"/>
           </a:xfrm>
           <a:prstGeom prst="rect">
             <a:avLst/>
@@ -7743,8 +7883,8 @@
         </p:nvSpPr>
         <p:spPr>
           <a:xfrm>
-            <a:off x="2224088" y="3371850"/>
-            <a:ext cx="1376363" cy="566738"/>
+            <a:off x="2224088" y="3298372"/>
+            <a:ext cx="1376363" cy="736826"/>
           </a:xfrm>
           <a:prstGeom prst="rect">
             <a:avLst/>
@@ -7753,7 +7893,7 @@
           <a:ln/>
         </p:spPr>
         <p:txBody>
-          <a:bodyPr wrap="square" lIns="0" tIns="0" rIns="0" bIns="0" rtlCol="0" anchor="ctr"/>
+          <a:bodyPr wrap="square" lIns="0" tIns="0" rIns="0" bIns="0" rtlCol="0" anchor="t"/>
           <a:lstStyle/>
           <a:p>
             <a:pPr marL="0" indent="0" algn="l">
@@ -7787,8 +7927,8 @@
         </p:nvSpPr>
         <p:spPr>
           <a:xfrm>
-            <a:off x="3952875" y="966788"/>
-            <a:ext cx="676275" cy="247650"/>
+            <a:off x="3952875" y="893310"/>
+            <a:ext cx="1376363" cy="247650"/>
           </a:xfrm>
           <a:prstGeom prst="rect">
             <a:avLst/>
@@ -7831,8 +7971,8 @@
         </p:nvSpPr>
         <p:spPr>
           <a:xfrm>
-            <a:off x="3952875" y="1271588"/>
-            <a:ext cx="1376363" cy="566738"/>
+            <a:off x="3952875" y="1198110"/>
+            <a:ext cx="1376363" cy="736826"/>
           </a:xfrm>
           <a:prstGeom prst="rect">
             <a:avLst/>
@@ -7841,7 +7981,7 @@
           <a:ln/>
         </p:spPr>
         <p:txBody>
-          <a:bodyPr wrap="square" lIns="0" tIns="0" rIns="0" bIns="0" rtlCol="0" anchor="ctr"/>
+          <a:bodyPr wrap="square" lIns="0" tIns="0" rIns="0" bIns="0" rtlCol="0" anchor="t"/>
           <a:lstStyle/>
           <a:p>
             <a:pPr marL="0" indent="0" algn="l">
@@ -7875,8 +8015,8 @@
         </p:nvSpPr>
         <p:spPr>
           <a:xfrm>
-            <a:off x="5686425" y="966788"/>
-            <a:ext cx="666750" cy="247650"/>
+            <a:off x="5686425" y="893310"/>
+            <a:ext cx="1356978" cy="247650"/>
           </a:xfrm>
           <a:prstGeom prst="rect">
             <a:avLst/>
@@ -7919,8 +8059,8 @@
         </p:nvSpPr>
         <p:spPr>
           <a:xfrm>
-            <a:off x="5686425" y="1271588"/>
-            <a:ext cx="1376363" cy="566738"/>
+            <a:off x="5686425" y="1198110"/>
+            <a:ext cx="1376363" cy="736826"/>
           </a:xfrm>
           <a:prstGeom prst="rect">
             <a:avLst/>
@@ -7929,7 +8069,7 @@
           <a:ln/>
         </p:spPr>
         <p:txBody>
-          <a:bodyPr wrap="square" lIns="0" tIns="0" rIns="0" bIns="0" rtlCol="0" anchor="ctr"/>
+          <a:bodyPr wrap="square" lIns="0" tIns="0" rIns="0" bIns="0" rtlCol="0" anchor="t"/>
           <a:lstStyle/>
           <a:p>
             <a:pPr marL="0" indent="0" algn="l">
@@ -7963,8 +8103,8 @@
         </p:nvSpPr>
         <p:spPr>
           <a:xfrm>
-            <a:off x="7415213" y="966788"/>
-            <a:ext cx="666750" cy="247650"/>
+            <a:off x="7415213" y="893310"/>
+            <a:ext cx="1356978" cy="247650"/>
           </a:xfrm>
           <a:prstGeom prst="rect">
             <a:avLst/>
@@ -8007,8 +8147,8 @@
         </p:nvSpPr>
         <p:spPr>
           <a:xfrm>
-            <a:off x="7415213" y="1271588"/>
-            <a:ext cx="1376363" cy="566738"/>
+            <a:off x="7415213" y="1198110"/>
+            <a:ext cx="1376363" cy="736826"/>
           </a:xfrm>
           <a:prstGeom prst="rect">
             <a:avLst/>
@@ -8017,7 +8157,7 @@
           <a:ln/>
         </p:spPr>
         <p:txBody>
-          <a:bodyPr wrap="square" lIns="0" tIns="0" rIns="0" bIns="0" rtlCol="0" anchor="ctr"/>
+          <a:bodyPr wrap="square" lIns="0" tIns="0" rIns="0" bIns="0" rtlCol="0" anchor="t"/>
           <a:lstStyle/>
           <a:p>
             <a:pPr marL="0" indent="0" algn="l">
@@ -8048,6 +8188,18 @@
   <p:clrMapOvr>
     <a:masterClrMapping/>
   </p:clrMapOvr>
+  <mc:AlternateContent xmlns:mc="http://schemas.openxmlformats.org/markup-compatibility/2006">
+    <mc:Choice xmlns:p14="http://schemas.microsoft.com/office/powerpoint/2010/main" Requires="p14">
+      <p:transition spd="med" p14:dur="700">
+        <p:fade/>
+      </p:transition>
+    </mc:Choice>
+    <mc:Fallback>
+      <p:transition spd="med">
+        <p:fade/>
+      </p:transition>
+    </mc:Fallback>
+  </mc:AlternateContent>
 </p:sld>
 </file>
 
@@ -8161,7 +8313,7 @@
           <a:ln/>
         </p:spPr>
         <p:txBody>
-          <a:bodyPr wrap="square" lIns="0" tIns="0" rIns="0" bIns="0" rtlCol="0" anchor="ctr"/>
+          <a:bodyPr wrap="square" lIns="0" tIns="0" rIns="0" bIns="0" rtlCol="0" anchor="t"/>
           <a:lstStyle/>
           <a:p>
             <a:pPr marL="0" indent="0" algn="l">
@@ -8217,7 +8369,7 @@
         </p:nvSpPr>
         <p:spPr>
           <a:xfrm>
-            <a:off x="4381500" y="1471494"/>
+            <a:off x="4381500" y="1332701"/>
             <a:ext cx="4286250" cy="225346"/>
           </a:xfrm>
           <a:prstGeom prst="rect">
@@ -8227,7 +8379,7 @@
           <a:ln/>
         </p:spPr>
         <p:txBody>
-          <a:bodyPr wrap="square" lIns="0" tIns="0" rIns="0" bIns="0" rtlCol="0" anchor="ctr"/>
+          <a:bodyPr wrap="square" lIns="0" tIns="0" rIns="0" bIns="0" rtlCol="0" anchor="t"/>
           <a:lstStyle/>
           <a:p>
             <a:pPr marL="0" indent="0" algn="l">
@@ -8271,7 +8423,7 @@
           <a:ln/>
         </p:spPr>
         <p:txBody>
-          <a:bodyPr wrap="square" lIns="0" tIns="0" rIns="0" bIns="0" rtlCol="0" anchor="ctr"/>
+          <a:bodyPr wrap="square" lIns="0" tIns="0" rIns="0" bIns="0" rtlCol="0" anchor="t"/>
           <a:lstStyle/>
           <a:p>
             <a:pPr marL="0" indent="0" algn="l">
@@ -8305,7 +8457,7 @@
         </p:nvSpPr>
         <p:spPr>
           <a:xfrm>
-            <a:off x="4381500" y="2919294"/>
+            <a:off x="4381500" y="2780501"/>
             <a:ext cx="4286250" cy="226636"/>
           </a:xfrm>
           <a:prstGeom prst="rect">
@@ -8315,7 +8467,7 @@
           <a:ln/>
         </p:spPr>
         <p:txBody>
-          <a:bodyPr wrap="square" lIns="0" tIns="0" rIns="0" bIns="0" rtlCol="0" anchor="ctr"/>
+          <a:bodyPr wrap="square" lIns="0" tIns="0" rIns="0" bIns="0" rtlCol="0" anchor="t"/>
           <a:lstStyle/>
           <a:p>
             <a:pPr marL="0" indent="0" algn="l">
@@ -8359,7 +8511,7 @@
           <a:ln/>
         </p:spPr>
         <p:txBody>
-          <a:bodyPr wrap="square" lIns="0" tIns="0" rIns="0" bIns="0" rtlCol="0" anchor="ctr"/>
+          <a:bodyPr wrap="square" lIns="0" tIns="0" rIns="0" bIns="0" rtlCol="0" anchor="t"/>
           <a:lstStyle/>
           <a:p>
             <a:pPr marL="0" indent="0" algn="l">
@@ -8457,6 +8609,18 @@
   <p:clrMapOvr>
     <a:masterClrMapping/>
   </p:clrMapOvr>
+  <mc:AlternateContent xmlns:mc="http://schemas.openxmlformats.org/markup-compatibility/2006">
+    <mc:Choice xmlns:p14="http://schemas.microsoft.com/office/powerpoint/2010/main" Requires="p14">
+      <p:transition spd="med" p14:dur="700">
+        <p:fade/>
+      </p:transition>
+    </mc:Choice>
+    <mc:Fallback>
+      <p:transition spd="med">
+        <p:fade/>
+      </p:transition>
+    </mc:Fallback>
+  </mc:AlternateContent>
 </p:sld>
 </file>
 
@@ -8570,7 +8734,7 @@
           <a:ln/>
         </p:spPr>
         <p:txBody>
-          <a:bodyPr wrap="square" lIns="0" tIns="0" rIns="0" bIns="0" rtlCol="0" anchor="ctr"/>
+          <a:bodyPr wrap="square" lIns="0" tIns="0" rIns="0" bIns="0" rtlCol="0" anchor="t"/>
           <a:lstStyle/>
           <a:p>
             <a:pPr marL="0" indent="0" algn="l">
@@ -8636,7 +8800,7 @@
           <a:ln/>
         </p:spPr>
         <p:txBody>
-          <a:bodyPr wrap="square" lIns="0" tIns="0" rIns="0" bIns="0" rtlCol="0" anchor="ctr"/>
+          <a:bodyPr wrap="square" lIns="0" tIns="0" rIns="0" bIns="0" rtlCol="0" anchor="t"/>
           <a:lstStyle/>
           <a:p>
             <a:pPr marL="0" indent="0" algn="l">
@@ -8670,8 +8834,8 @@
         </p:nvSpPr>
         <p:spPr>
           <a:xfrm>
-            <a:off x="485775" y="1635406"/>
-            <a:ext cx="4286250" cy="974444"/>
+            <a:off x="485775" y="1719966"/>
+            <a:ext cx="4286250" cy="805325"/>
           </a:xfrm>
           <a:prstGeom prst="rect">
             <a:avLst/>
@@ -8680,7 +8844,7 @@
           <a:ln/>
         </p:spPr>
         <p:txBody>
-          <a:bodyPr wrap="square" lIns="0" tIns="0" rIns="0" bIns="0" rtlCol="0" anchor="ctr"/>
+          <a:bodyPr wrap="square" lIns="0" tIns="0" rIns="0" bIns="0" rtlCol="0" anchor="t"/>
           <a:lstStyle/>
           <a:p>
             <a:pPr marL="0" indent="0" algn="l">
@@ -8724,7 +8888,7 @@
           <a:ln/>
         </p:spPr>
         <p:txBody>
-          <a:bodyPr wrap="square" lIns="0" tIns="0" rIns="0" bIns="0" rtlCol="0" anchor="ctr"/>
+          <a:bodyPr wrap="square" lIns="0" tIns="0" rIns="0" bIns="0" rtlCol="0" anchor="t"/>
           <a:lstStyle/>
           <a:p>
             <a:pPr marL="0" indent="0" algn="l">
@@ -8758,8 +8922,8 @@
         </p:nvSpPr>
         <p:spPr>
           <a:xfrm>
-            <a:off x="485775" y="3082465"/>
-            <a:ext cx="4286250" cy="975185"/>
+            <a:off x="485775" y="3167088"/>
+            <a:ext cx="4286250" cy="805938"/>
           </a:xfrm>
           <a:prstGeom prst="rect">
             <a:avLst/>
@@ -8768,7 +8932,7 @@
           <a:ln/>
         </p:spPr>
         <p:txBody>
-          <a:bodyPr wrap="square" lIns="0" tIns="0" rIns="0" bIns="0" rtlCol="0" anchor="ctr"/>
+          <a:bodyPr wrap="square" lIns="0" tIns="0" rIns="0" bIns="0" rtlCol="0" anchor="t"/>
           <a:lstStyle/>
           <a:p>
             <a:pPr marL="0" indent="0" algn="l">
@@ -8866,6 +9030,18 @@
   <p:clrMapOvr>
     <a:masterClrMapping/>
   </p:clrMapOvr>
+  <mc:AlternateContent xmlns:mc="http://schemas.openxmlformats.org/markup-compatibility/2006">
+    <mc:Choice xmlns:p14="http://schemas.microsoft.com/office/powerpoint/2010/main" Requires="p14">
+      <p:transition spd="med" p14:dur="700">
+        <p:fade/>
+      </p:transition>
+    </mc:Choice>
+    <mc:Fallback>
+      <p:transition spd="med">
+        <p:fade/>
+      </p:transition>
+    </mc:Fallback>
+  </mc:AlternateContent>
 </p:sld>
 </file>
 
@@ -21105,7 +21281,7 @@
           <a:ln/>
         </p:spPr>
         <p:txBody>
-          <a:bodyPr wrap="square" lIns="0" tIns="0" rIns="0" bIns="0" rtlCol="0" anchor="ctr"/>
+          <a:bodyPr wrap="square" lIns="0" tIns="0" rIns="0" bIns="0" rtlCol="0" anchor="t"/>
           <a:lstStyle/>
           <a:p>
             <a:pPr marL="0" indent="0" algn="l">
@@ -21158,6 +21334,18 @@
   <p:clrMapOvr>
     <a:masterClrMapping/>
   </p:clrMapOvr>
+  <mc:AlternateContent xmlns:mc="http://schemas.openxmlformats.org/markup-compatibility/2006">
+    <mc:Choice xmlns:p14="http://schemas.microsoft.com/office/powerpoint/2010/main" Requires="p14">
+      <p:transition spd="med" p14:dur="700">
+        <p:fade/>
+      </p:transition>
+    </mc:Choice>
+    <mc:Fallback>
+      <p:transition spd="med">
+        <p:fade/>
+      </p:transition>
+    </mc:Fallback>
+  </mc:AlternateContent>
 </p:sld>
 </file>
 
@@ -21716,6 +21904,18 @@
   <p:clrMapOvr>
     <a:masterClrMapping/>
   </p:clrMapOvr>
+  <mc:AlternateContent xmlns:mc="http://schemas.openxmlformats.org/markup-compatibility/2006">
+    <mc:Choice xmlns:p14="http://schemas.microsoft.com/office/powerpoint/2010/main" Requires="p14">
+      <p:transition spd="med" p14:dur="700">
+        <p:fade/>
+      </p:transition>
+    </mc:Choice>
+    <mc:Fallback>
+      <p:transition spd="med">
+        <p:fade/>
+      </p:transition>
+    </mc:Fallback>
+  </mc:AlternateContent>
 </p:sld>
 </file>
 
@@ -22117,7 +22317,7 @@
           <a:ln/>
         </p:spPr>
         <p:txBody>
-          <a:bodyPr wrap="square" lIns="0" tIns="0" rIns="0" bIns="0" rtlCol="0" anchor="ctr"/>
+          <a:bodyPr wrap="square" lIns="0" tIns="0" rIns="0" bIns="0" rtlCol="0" anchor="t"/>
           <a:lstStyle/>
           <a:p>
             <a:pPr marL="0" indent="0" algn="l">
@@ -22161,7 +22361,7 @@
           <a:ln/>
         </p:spPr>
         <p:txBody>
-          <a:bodyPr wrap="square" lIns="0" tIns="0" rIns="0" bIns="0" rtlCol="0" anchor="ctr"/>
+          <a:bodyPr wrap="square" lIns="0" tIns="0" rIns="0" bIns="0" rtlCol="0" anchor="t"/>
           <a:lstStyle/>
           <a:p>
             <a:pPr marL="0" indent="0" algn="l">
@@ -22269,7 +22469,7 @@
           <a:ln/>
         </p:spPr>
         <p:txBody>
-          <a:bodyPr wrap="square" lIns="0" tIns="0" rIns="0" bIns="0" rtlCol="0" anchor="ctr"/>
+          <a:bodyPr wrap="square" lIns="0" tIns="0" rIns="0" bIns="0" rtlCol="0" anchor="t"/>
           <a:lstStyle/>
           <a:p>
             <a:pPr marL="0" indent="0" algn="l">
@@ -22377,7 +22577,7 @@
           <a:ln/>
         </p:spPr>
         <p:txBody>
-          <a:bodyPr wrap="square" lIns="0" tIns="0" rIns="0" bIns="0" rtlCol="0" anchor="ctr"/>
+          <a:bodyPr wrap="square" lIns="0" tIns="0" rIns="0" bIns="0" rtlCol="0" anchor="t"/>
           <a:lstStyle/>
           <a:p>
             <a:pPr marL="0" indent="0" algn="l">
@@ -22387,19 +22587,21 @@
               <a:buNone/>
             </a:pPr>
             <a:r>
-              <a:rPr lang="en-US" sz="1710" b="1" kern="0" spc="-34" dirty="0">
+              <a:rPr lang="en-US" sz="1710" kern="0" spc="-34" dirty="0">
                 <a:solidFill>
                   <a:srgbClr val="FFFFFF">
                     <a:alpha val="99000"/>
                   </a:srgbClr>
                 </a:solidFill>
-                <a:latin typeface="Manrope" pitchFamily="34" charset="0"/>
+                <a:latin typeface="Manrope" pitchFamily="2" charset="0"/>
                 <a:ea typeface="Manrope" pitchFamily="34" charset="-122"/>
                 <a:cs typeface="Manrope" pitchFamily="34" charset="-120"/>
               </a:rPr>
               <a:t>Christopher Fabian  </a:t>
             </a:r>
-            <a:endParaRPr lang="en-US" sz="1710" dirty="0"/>
+            <a:endParaRPr lang="en-US" sz="1710" dirty="0">
+              <a:latin typeface="Manrope" pitchFamily="2" charset="0"/>
+            </a:endParaRPr>
           </a:p>
         </p:txBody>
       </p:sp>
@@ -22421,7 +22623,7 @@
           <a:ln/>
         </p:spPr>
         <p:txBody>
-          <a:bodyPr wrap="square" lIns="0" tIns="0" rIns="0" bIns="0" rtlCol="0" anchor="ctr"/>
+          <a:bodyPr wrap="square" lIns="0" tIns="0" rIns="0" bIns="0" rtlCol="0" anchor="t"/>
           <a:lstStyle/>
           <a:p>
             <a:pPr marL="0" indent="0" algn="l">
@@ -22431,19 +22633,21 @@
               <a:buNone/>
             </a:pPr>
             <a:r>
-              <a:rPr lang="en-US" sz="1710" b="1" kern="0" spc="-34" dirty="0">
+              <a:rPr lang="en-US" sz="1710" kern="0" spc="-34" dirty="0">
                 <a:solidFill>
                   <a:srgbClr val="FFFFFF">
                     <a:alpha val="99000"/>
                   </a:srgbClr>
                 </a:solidFill>
-                <a:latin typeface="Manrope" pitchFamily="34" charset="0"/>
+                <a:latin typeface="Manrope" pitchFamily="2" charset="0"/>
                 <a:ea typeface="Manrope" pitchFamily="34" charset="-122"/>
                 <a:cs typeface="Manrope" pitchFamily="34" charset="-120"/>
               </a:rPr>
               <a:t>Name Surname</a:t>
             </a:r>
-            <a:endParaRPr lang="en-US" sz="1710" dirty="0"/>
+            <a:endParaRPr lang="en-US" sz="1710" dirty="0">
+              <a:latin typeface="Manrope" pitchFamily="2" charset="0"/>
+            </a:endParaRPr>
           </a:p>
         </p:txBody>
       </p:sp>
@@ -22452,6 +22656,18 @@
   <p:clrMapOvr>
     <a:masterClrMapping/>
   </p:clrMapOvr>
+  <mc:AlternateContent xmlns:mc="http://schemas.openxmlformats.org/markup-compatibility/2006">
+    <mc:Choice xmlns:p14="http://schemas.microsoft.com/office/powerpoint/2010/main" Requires="p14">
+      <p:transition spd="med" p14:dur="700">
+        <p:fade/>
+      </p:transition>
+    </mc:Choice>
+    <mc:Fallback>
+      <p:transition spd="med">
+        <p:fade/>
+      </p:transition>
+    </mc:Fallback>
+  </mc:AlternateContent>
 </p:sld>
 </file>
 
@@ -22521,7 +22737,7 @@
           <a:ln/>
         </p:spPr>
         <p:txBody>
-          <a:bodyPr wrap="square" lIns="0" tIns="0" rIns="0" bIns="0" rtlCol="0" anchor="ctr"/>
+          <a:bodyPr wrap="square" lIns="0" tIns="0" rIns="0" bIns="0" rtlCol="0" anchor="t"/>
           <a:lstStyle/>
           <a:p>
             <a:pPr marL="0" indent="0" algn="l">
@@ -22587,7 +22803,7 @@
           <a:ln/>
         </p:spPr>
         <p:txBody>
-          <a:bodyPr wrap="square" lIns="0" tIns="0" rIns="0" bIns="0" rtlCol="0" anchor="ctr"/>
+          <a:bodyPr wrap="square" lIns="0" tIns="0" rIns="0" bIns="0" rtlCol="0" anchor="t"/>
           <a:lstStyle/>
           <a:p>
             <a:pPr marL="0" indent="0" algn="l">
@@ -22631,7 +22847,7 @@
           <a:ln/>
         </p:spPr>
         <p:txBody>
-          <a:bodyPr wrap="square" lIns="0" tIns="0" rIns="0" bIns="0" rtlCol="0" anchor="ctr"/>
+          <a:bodyPr wrap="square" lIns="0" tIns="0" rIns="0" bIns="0" rtlCol="0" anchor="t"/>
           <a:lstStyle/>
           <a:p>
             <a:pPr marL="0" indent="0" algn="l">
@@ -22675,7 +22891,7 @@
           <a:ln/>
         </p:spPr>
         <p:txBody>
-          <a:bodyPr wrap="square" lIns="0" tIns="0" rIns="0" bIns="0" rtlCol="0" anchor="ctr"/>
+          <a:bodyPr wrap="square" lIns="0" tIns="0" rIns="0" bIns="0" rtlCol="0" anchor="t"/>
           <a:lstStyle/>
           <a:p>
             <a:pPr marL="0" indent="0" algn="l">
@@ -22719,7 +22935,7 @@
           <a:ln/>
         </p:spPr>
         <p:txBody>
-          <a:bodyPr wrap="square" lIns="0" tIns="0" rIns="0" bIns="0" rtlCol="0" anchor="ctr"/>
+          <a:bodyPr wrap="none" lIns="0" tIns="0" rIns="0" bIns="0" rtlCol="0" anchor="t"/>
           <a:lstStyle/>
           <a:p>
             <a:pPr marL="0" indent="0" algn="l">
@@ -22741,7 +22957,6 @@
               </a:rPr>
               <a:t>One sentence on what the partner provides</a:t>
             </a:r>
-            <a:endParaRPr lang="en-US" sz="1069" dirty="0"/>
           </a:p>
         </p:txBody>
       </p:sp>
@@ -22763,7 +22978,7 @@
           <a:ln/>
         </p:spPr>
         <p:txBody>
-          <a:bodyPr wrap="square" lIns="0" tIns="0" rIns="0" bIns="0" rtlCol="0" anchor="ctr"/>
+          <a:bodyPr wrap="square" lIns="0" tIns="0" rIns="0" bIns="0" rtlCol="0" anchor="t"/>
           <a:lstStyle/>
           <a:p>
             <a:pPr marL="0" indent="0" algn="l">
@@ -22807,7 +23022,7 @@
           <a:ln/>
         </p:spPr>
         <p:txBody>
-          <a:bodyPr wrap="square" lIns="0" tIns="0" rIns="0" bIns="0" rtlCol="0" anchor="ctr"/>
+          <a:bodyPr wrap="square" lIns="0" tIns="0" rIns="0" bIns="0" rtlCol="0" anchor="t"/>
           <a:lstStyle/>
           <a:p>
             <a:pPr marL="0" indent="0" algn="l">
@@ -22851,7 +23066,7 @@
           <a:ln/>
         </p:spPr>
         <p:txBody>
-          <a:bodyPr wrap="square" lIns="0" tIns="0" rIns="0" bIns="0" rtlCol="0" anchor="ctr"/>
+          <a:bodyPr wrap="square" lIns="0" tIns="0" rIns="0" bIns="0" rtlCol="0" anchor="t"/>
           <a:lstStyle/>
           <a:p>
             <a:pPr marL="0" indent="0" algn="l">
@@ -22895,7 +23110,7 @@
           <a:ln/>
         </p:spPr>
         <p:txBody>
-          <a:bodyPr wrap="square" lIns="0" tIns="0" rIns="0" bIns="0" rtlCol="0" anchor="ctr"/>
+          <a:bodyPr wrap="square" lIns="0" tIns="0" rIns="0" bIns="0" rtlCol="0" anchor="t"/>
           <a:lstStyle/>
           <a:p>
             <a:pPr marL="0" indent="0" algn="l">
@@ -22939,7 +23154,7 @@
           <a:ln/>
         </p:spPr>
         <p:txBody>
-          <a:bodyPr wrap="square" lIns="0" tIns="0" rIns="0" bIns="0" rtlCol="0" anchor="ctr"/>
+          <a:bodyPr wrap="square" lIns="0" tIns="0" rIns="0" bIns="0" rtlCol="0" anchor="t"/>
           <a:lstStyle/>
           <a:p>
             <a:pPr marL="0" indent="0" algn="l">
@@ -22974,7 +23189,7 @@
         <p:spPr>
           <a:xfrm>
             <a:off x="476250" y="4086168"/>
-            <a:ext cx="4286250" cy="390525"/>
+            <a:ext cx="4286250" cy="357816"/>
           </a:xfrm>
           <a:prstGeom prst="rect">
             <a:avLst/>
@@ -22983,7 +23198,9 @@
           <a:ln/>
         </p:spPr>
         <p:txBody>
-          <a:bodyPr wrap="square" lIns="0" tIns="0" rIns="0" bIns="0" rtlCol="0" anchor="t"/>
+          <a:bodyPr wrap="none" lIns="0" tIns="0" rIns="0" bIns="0" rtlCol="0" anchor="t">
+            <a:noAutofit/>
+          </a:bodyPr>
           <a:lstStyle/>
           <a:p>
             <a:pPr marL="0" indent="0" algn="l">
@@ -23005,7 +23222,6 @@
               </a:rPr>
               <a:t>Maximum two sentences of additional context if absolutely needed</a:t>
             </a:r>
-            <a:endParaRPr lang="en-US" sz="1069" dirty="0"/>
           </a:p>
         </p:txBody>
       </p:sp>
@@ -23037,6 +23253,18 @@
   <p:clrMapOvr>
     <a:masterClrMapping/>
   </p:clrMapOvr>
+  <mc:AlternateContent xmlns:mc="http://schemas.openxmlformats.org/markup-compatibility/2006">
+    <mc:Choice xmlns:p14="http://schemas.microsoft.com/office/powerpoint/2010/main" Requires="p14">
+      <p:transition spd="med" p14:dur="700">
+        <p:fade/>
+      </p:transition>
+    </mc:Choice>
+    <mc:Fallback>
+      <p:transition spd="med">
+        <p:fade/>
+      </p:transition>
+    </mc:Fallback>
+  </mc:AlternateContent>
 </p:sld>
 </file>
 
@@ -23106,7 +23334,7 @@
           <a:ln/>
         </p:spPr>
         <p:txBody>
-          <a:bodyPr wrap="square" lIns="0" tIns="0" rIns="0" bIns="0" rtlCol="0" anchor="ctr"/>
+          <a:bodyPr wrap="square" lIns="0" tIns="0" rIns="0" bIns="0" rtlCol="0" anchor="t"/>
           <a:lstStyle/>
           <a:p>
             <a:pPr marL="0" indent="0" algn="l">
@@ -23222,7 +23450,7 @@
           <a:ln/>
         </p:spPr>
         <p:txBody>
-          <a:bodyPr wrap="square" lIns="0" tIns="0" rIns="0" bIns="0" rtlCol="0" anchor="ctr"/>
+          <a:bodyPr wrap="square" lIns="0" tIns="0" rIns="0" bIns="0" rtlCol="0" anchor="t"/>
           <a:lstStyle/>
           <a:p>
             <a:pPr marL="0" indent="0" algn="l">
@@ -23272,7 +23500,7 @@
           <a:ln/>
         </p:spPr>
         <p:txBody>
-          <a:bodyPr wrap="square" lIns="0" tIns="0" rIns="0" bIns="0" rtlCol="0" anchor="ctr"/>
+          <a:bodyPr wrap="square" lIns="0" tIns="0" rIns="0" bIns="0" rtlCol="0" anchor="t"/>
           <a:lstStyle/>
           <a:p>
             <a:pPr marL="0" indent="0" algn="l">
@@ -23322,7 +23550,7 @@
           <a:ln/>
         </p:spPr>
         <p:txBody>
-          <a:bodyPr wrap="square" lIns="0" tIns="0" rIns="0" bIns="0" rtlCol="0" anchor="ctr"/>
+          <a:bodyPr wrap="square" lIns="0" tIns="0" rIns="0" bIns="0" rtlCol="0" anchor="t"/>
           <a:lstStyle/>
           <a:p>
             <a:pPr marL="0" indent="0" algn="l">
@@ -23372,7 +23600,7 @@
           <a:ln/>
         </p:spPr>
         <p:txBody>
-          <a:bodyPr wrap="square" lIns="0" tIns="0" rIns="0" bIns="0" rtlCol="0" anchor="ctr"/>
+          <a:bodyPr wrap="square" lIns="0" tIns="0" rIns="0" bIns="0" rtlCol="0" anchor="t"/>
           <a:lstStyle/>
           <a:p>
             <a:pPr marL="0" indent="0" algn="l">
@@ -23422,7 +23650,7 @@
           <a:ln/>
         </p:spPr>
         <p:txBody>
-          <a:bodyPr wrap="square" lIns="0" tIns="0" rIns="0" bIns="0" rtlCol="0" anchor="ctr"/>
+          <a:bodyPr wrap="square" lIns="0" tIns="0" rIns="0" bIns="0" rtlCol="0" anchor="t"/>
           <a:lstStyle/>
           <a:p>
             <a:pPr marL="0" indent="0" algn="l">
@@ -23472,7 +23700,7 @@
           <a:ln/>
         </p:spPr>
         <p:txBody>
-          <a:bodyPr wrap="square" lIns="0" tIns="0" rIns="0" bIns="0" rtlCol="0" anchor="ctr"/>
+          <a:bodyPr wrap="square" lIns="0" tIns="0" rIns="0" bIns="0" rtlCol="0" anchor="t"/>
           <a:lstStyle/>
           <a:p>
             <a:pPr marL="0" indent="0" algn="l">
@@ -23522,7 +23750,7 @@
           <a:ln/>
         </p:spPr>
         <p:txBody>
-          <a:bodyPr wrap="square" lIns="0" tIns="0" rIns="0" bIns="0" rtlCol="0" anchor="ctr"/>
+          <a:bodyPr wrap="square" lIns="0" tIns="0" rIns="0" bIns="0" rtlCol="0" anchor="t"/>
           <a:lstStyle/>
           <a:p>
             <a:pPr marL="0" indent="0" algn="l">
@@ -23572,7 +23800,7 @@
           <a:ln/>
         </p:spPr>
         <p:txBody>
-          <a:bodyPr wrap="square" lIns="0" tIns="0" rIns="0" bIns="0" rtlCol="0" anchor="ctr"/>
+          <a:bodyPr wrap="square" lIns="0" tIns="0" rIns="0" bIns="0" rtlCol="0" anchor="t"/>
           <a:lstStyle/>
           <a:p>
             <a:pPr marL="0" indent="0" algn="l">
@@ -23622,7 +23850,7 @@
           <a:ln/>
         </p:spPr>
         <p:txBody>
-          <a:bodyPr wrap="square" lIns="0" tIns="0" rIns="0" bIns="0" rtlCol="0" anchor="ctr"/>
+          <a:bodyPr wrap="square" lIns="0" tIns="0" rIns="0" bIns="0" rtlCol="0" anchor="t"/>
           <a:lstStyle/>
           <a:p>
             <a:pPr marL="0" indent="0" algn="l">
@@ -23703,6 +23931,18 @@
   <p:clrMapOvr>
     <a:masterClrMapping/>
   </p:clrMapOvr>
+  <mc:AlternateContent xmlns:mc="http://schemas.openxmlformats.org/markup-compatibility/2006">
+    <mc:Choice xmlns:p14="http://schemas.microsoft.com/office/powerpoint/2010/main" Requires="p14">
+      <p:transition spd="med" p14:dur="700">
+        <p:fade/>
+      </p:transition>
+    </mc:Choice>
+    <mc:Fallback>
+      <p:transition spd="med">
+        <p:fade/>
+      </p:transition>
+    </mc:Fallback>
+  </mc:AlternateContent>
 </p:sld>
 </file>
 
@@ -23847,6 +24087,18 @@
   <p:clrMapOvr>
     <a:masterClrMapping/>
   </p:clrMapOvr>
+  <mc:AlternateContent xmlns:mc="http://schemas.openxmlformats.org/markup-compatibility/2006">
+    <mc:Choice xmlns:p14="http://schemas.microsoft.com/office/powerpoint/2010/main" Requires="p14">
+      <p:transition spd="med" p14:dur="700">
+        <p:fade/>
+      </p:transition>
+    </mc:Choice>
+    <mc:Fallback>
+      <p:transition spd="med">
+        <p:fade/>
+      </p:transition>
+    </mc:Fallback>
+  </mc:AlternateContent>
 </p:sld>
 </file>
 
@@ -23937,7 +24189,7 @@
           <a:ln/>
         </p:spPr>
         <p:txBody>
-          <a:bodyPr wrap="square" lIns="0" tIns="0" rIns="0" bIns="0" rtlCol="0" anchor="ctr"/>
+          <a:bodyPr wrap="square" lIns="0" tIns="0" rIns="0" bIns="0" rtlCol="0" anchor="t"/>
           <a:lstStyle/>
           <a:p>
             <a:pPr marL="0" indent="0" algn="l">
@@ -24130,7 +24382,7 @@
           <a:ln/>
         </p:spPr>
         <p:txBody>
-          <a:bodyPr wrap="square" lIns="0" tIns="0" rIns="0" bIns="0" rtlCol="0" anchor="ctr"/>
+          <a:bodyPr wrap="square" lIns="0" tIns="0" rIns="0" bIns="0" rtlCol="0" anchor="t"/>
           <a:lstStyle/>
           <a:p>
             <a:r>
@@ -24297,7 +24549,7 @@
           <a:ln/>
         </p:spPr>
         <p:txBody>
-          <a:bodyPr wrap="square" lIns="0" tIns="0" rIns="0" bIns="0" rtlCol="0" anchor="ctr"/>
+          <a:bodyPr wrap="square" lIns="0" tIns="0" rIns="0" bIns="0" rtlCol="0" anchor="t"/>
           <a:lstStyle/>
           <a:p>
             <a:r>
@@ -24464,7 +24716,7 @@
           <a:ln/>
         </p:spPr>
         <p:txBody>
-          <a:bodyPr wrap="square" lIns="0" tIns="0" rIns="0" bIns="0" rtlCol="0" anchor="ctr"/>
+          <a:bodyPr wrap="square" lIns="0" tIns="0" rIns="0" bIns="0" rtlCol="0" anchor="t"/>
           <a:lstStyle/>
           <a:p>
             <a:r>
@@ -24631,7 +24883,7 @@
           <a:ln/>
         </p:spPr>
         <p:txBody>
-          <a:bodyPr wrap="square" lIns="0" tIns="0" rIns="0" bIns="0" rtlCol="0" anchor="ctr"/>
+          <a:bodyPr wrap="square" lIns="0" tIns="0" rIns="0" bIns="0" rtlCol="0" anchor="t"/>
           <a:lstStyle/>
           <a:p>
             <a:r>
@@ -24703,6 +24955,18 @@
   <p:clrMapOvr>
     <a:masterClrMapping/>
   </p:clrMapOvr>
+  <mc:AlternateContent xmlns:mc="http://schemas.openxmlformats.org/markup-compatibility/2006">
+    <mc:Choice xmlns:p14="http://schemas.microsoft.com/office/powerpoint/2010/main" Requires="p14">
+      <p:transition spd="med" p14:dur="700">
+        <p:fade/>
+      </p:transition>
+    </mc:Choice>
+    <mc:Fallback>
+      <p:transition spd="med">
+        <p:fade/>
+      </p:transition>
+    </mc:Fallback>
+  </mc:AlternateContent>
 </p:sld>
 </file>
 
@@ -25323,7 +25587,7 @@
           <a:ln/>
         </p:spPr>
         <p:txBody>
-          <a:bodyPr wrap="square" lIns="0" tIns="0" rIns="0" bIns="0" rtlCol="0" anchor="ctr"/>
+          <a:bodyPr wrap="square" lIns="0" tIns="0" rIns="0" bIns="0" rtlCol="0" anchor="t"/>
           <a:lstStyle/>
           <a:p>
             <a:r>
@@ -25365,7 +25629,7 @@
           <a:ln/>
         </p:spPr>
         <p:txBody>
-          <a:bodyPr wrap="square" lIns="0" tIns="0" rIns="0" bIns="0" rtlCol="0" anchor="ctr"/>
+          <a:bodyPr wrap="square" lIns="0" tIns="0" rIns="0" bIns="0" rtlCol="0" anchor="t"/>
           <a:lstStyle/>
           <a:p>
             <a:r>
@@ -25407,7 +25671,7 @@
           <a:ln/>
         </p:spPr>
         <p:txBody>
-          <a:bodyPr wrap="square" lIns="0" tIns="0" rIns="0" bIns="0" rtlCol="0" anchor="ctr"/>
+          <a:bodyPr wrap="square" lIns="0" tIns="0" rIns="0" bIns="0" rtlCol="0" anchor="t"/>
           <a:lstStyle/>
           <a:p>
             <a:r>
@@ -25449,7 +25713,7 @@
           <a:ln/>
         </p:spPr>
         <p:txBody>
-          <a:bodyPr wrap="square" lIns="0" tIns="0" rIns="0" bIns="0" rtlCol="0" anchor="ctr"/>
+          <a:bodyPr wrap="square" lIns="0" tIns="0" rIns="0" bIns="0" rtlCol="0" anchor="t"/>
           <a:lstStyle/>
           <a:p>
             <a:r>
@@ -25872,6 +26136,18 @@
   <p:clrMapOvr>
     <a:masterClrMapping/>
   </p:clrMapOvr>
+  <mc:AlternateContent xmlns:mc="http://schemas.openxmlformats.org/markup-compatibility/2006">
+    <mc:Choice xmlns:p14="http://schemas.microsoft.com/office/powerpoint/2010/main" Requires="p14">
+      <p:transition spd="med" p14:dur="700">
+        <p:fade/>
+      </p:transition>
+    </mc:Choice>
+    <mc:Fallback>
+      <p:transition spd="med">
+        <p:fade/>
+      </p:transition>
+    </mc:Fallback>
+  </mc:AlternateContent>
 </p:sld>
 </file>
 
@@ -26201,7 +26477,7 @@
           <a:ln/>
         </p:spPr>
         <p:txBody>
-          <a:bodyPr wrap="square" lIns="0" tIns="0" rIns="0" bIns="0" rtlCol="0" anchor="ctr"/>
+          <a:bodyPr wrap="square" lIns="0" tIns="0" rIns="0" bIns="0" rtlCol="0" anchor="t"/>
           <a:lstStyle/>
           <a:p>
             <a:r>
@@ -26440,7 +26716,7 @@
           <a:ln/>
         </p:spPr>
         <p:txBody>
-          <a:bodyPr wrap="square" lIns="0" tIns="0" rIns="0" bIns="0" rtlCol="0" anchor="ctr"/>
+          <a:bodyPr wrap="square" lIns="0" tIns="0" rIns="0" bIns="0" rtlCol="0" anchor="t"/>
           <a:lstStyle/>
           <a:p>
             <a:r>
@@ -26677,7 +26953,7 @@
           <a:ln/>
         </p:spPr>
         <p:txBody>
-          <a:bodyPr wrap="square" lIns="0" tIns="0" rIns="0" bIns="0" rtlCol="0" anchor="ctr"/>
+          <a:bodyPr wrap="square" lIns="0" tIns="0" rIns="0" bIns="0" rtlCol="0" anchor="t"/>
           <a:lstStyle/>
           <a:p>
             <a:r>
@@ -26798,6 +27074,18 @@
   <p:clrMapOvr>
     <a:masterClrMapping/>
   </p:clrMapOvr>
+  <mc:AlternateContent xmlns:mc="http://schemas.openxmlformats.org/markup-compatibility/2006">
+    <mc:Choice xmlns:p14="http://schemas.microsoft.com/office/powerpoint/2010/main" Requires="p14">
+      <p:transition spd="med" p14:dur="700">
+        <p:fade/>
+      </p:transition>
+    </mc:Choice>
+    <mc:Fallback>
+      <p:transition spd="med">
+        <p:fade/>
+      </p:transition>
+    </mc:Fallback>
+  </mc:AlternateContent>
 </p:sld>
 </file>
 
@@ -27009,6 +27297,18 @@
   <p:clrMapOvr>
     <a:masterClrMapping/>
   </p:clrMapOvr>
+  <mc:AlternateContent xmlns:mc="http://schemas.openxmlformats.org/markup-compatibility/2006">
+    <mc:Choice xmlns:p14="http://schemas.microsoft.com/office/powerpoint/2010/main" Requires="p14">
+      <p:transition spd="med" p14:dur="700">
+        <p:fade/>
+      </p:transition>
+    </mc:Choice>
+    <mc:Fallback>
+      <p:transition spd="med">
+        <p:fade/>
+      </p:transition>
+    </mc:Fallback>
+  </mc:AlternateContent>
 </p:sld>
 </file>
 
@@ -27301,7 +27601,7 @@
   <a:extraClrSchemeLst/>
   <a:extLst>
     <a:ext uri="{05A4C25C-085E-4340-85A3-A5531E510DB2}">
-      <thm15:themeFamily xmlns:thm15="http://schemas.microsoft.com/office/thememl/2012/main" name="Office Theme" id="{62F939B6-93AF-4DB8-9C6B-D6C7DFDC589F}" vid="{4A3C46E8-61CC-4603-A589-7422A47A8E4A}"/>
+      <thm15:themeFamily xmlns:thm15="http://schemas.microsoft.com/office/thememl/2012/main" name="PPT giga" id="{D101DC1C-5471-0049-9B18-2A5725709A10}" vid="{DE5324F7-5D70-144F-BDBD-79020F46847D}"/>
     </a:ext>
   </a:extLst>
 </a:theme>

</xml_diff>

<commit_message>
Update PPT giga.pptx (Desktop)
Made-with: Cursor
</commit_message>
<xml_diff>
--- a/PPT giga.pptx
+++ b/PPT giga.pptx
@@ -5330,7 +5330,7 @@
           <a:ln/>
         </p:spPr>
         <p:txBody>
-          <a:bodyPr wrap="square" lIns="0" tIns="0" rIns="0" bIns="0" rtlCol="0" anchor="t">
+          <a:bodyPr wrap="square" lIns="0" tIns="0" rIns="0" bIns="0" rtlCol="0" anchor="b">
             <a:normAutofit/>
           </a:bodyPr>
           <a:lstStyle/>
@@ -5366,7 +5366,7 @@
         </p:nvSpPr>
         <p:spPr>
           <a:xfrm>
-            <a:off x="4476750" y="1200150"/>
+            <a:off x="4476750" y="1143002"/>
             <a:ext cx="1838325" cy="442913"/>
           </a:xfrm>
           <a:prstGeom prst="rect">
@@ -5447,7 +5447,7 @@
           <a:ln/>
         </p:spPr>
         <p:txBody>
-          <a:bodyPr wrap="square" lIns="0" tIns="0" rIns="0" bIns="0" rtlCol="0" anchor="t">
+          <a:bodyPr wrap="square" lIns="0" tIns="0" rIns="0" bIns="0" rtlCol="0" anchor="b">
             <a:normAutofit/>
           </a:bodyPr>
           <a:lstStyle/>
@@ -5483,7 +5483,7 @@
         </p:nvSpPr>
         <p:spPr>
           <a:xfrm>
-            <a:off x="4476750" y="2495550"/>
+            <a:off x="4476750" y="2438402"/>
             <a:ext cx="1838325" cy="442913"/>
           </a:xfrm>
           <a:prstGeom prst="rect">
@@ -5564,7 +5564,7 @@
           <a:ln/>
         </p:spPr>
         <p:txBody>
-          <a:bodyPr wrap="square" lIns="0" tIns="0" rIns="0" bIns="0" rtlCol="0" anchor="t">
+          <a:bodyPr wrap="square" lIns="0" tIns="0" rIns="0" bIns="0" rtlCol="0" anchor="b">
             <a:normAutofit/>
           </a:bodyPr>
           <a:lstStyle/>
@@ -5600,7 +5600,7 @@
         </p:nvSpPr>
         <p:spPr>
           <a:xfrm>
-            <a:off x="4476750" y="3790950"/>
+            <a:off x="4476750" y="3733802"/>
             <a:ext cx="1838325" cy="442913"/>
           </a:xfrm>
           <a:prstGeom prst="rect">
@@ -5681,7 +5681,7 @@
           <a:ln/>
         </p:spPr>
         <p:txBody>
-          <a:bodyPr wrap="square" lIns="0" tIns="0" rIns="0" bIns="0" rtlCol="0" anchor="t">
+          <a:bodyPr wrap="square" lIns="0" tIns="0" rIns="0" bIns="0" rtlCol="0" anchor="b">
             <a:normAutofit/>
           </a:bodyPr>
           <a:lstStyle/>
@@ -5717,7 +5717,7 @@
         </p:nvSpPr>
         <p:spPr>
           <a:xfrm>
-            <a:off x="6853238" y="1200150"/>
+            <a:off x="6853238" y="1143002"/>
             <a:ext cx="1838325" cy="442913"/>
           </a:xfrm>
           <a:prstGeom prst="rect">
@@ -5798,7 +5798,7 @@
           <a:ln/>
         </p:spPr>
         <p:txBody>
-          <a:bodyPr wrap="square" lIns="0" tIns="0" rIns="0" bIns="0" rtlCol="0" anchor="t">
+          <a:bodyPr wrap="square" lIns="0" tIns="0" rIns="0" bIns="0" rtlCol="0" anchor="b">
             <a:normAutofit/>
           </a:bodyPr>
           <a:lstStyle/>
@@ -5834,7 +5834,7 @@
         </p:nvSpPr>
         <p:spPr>
           <a:xfrm>
-            <a:off x="6853238" y="2495550"/>
+            <a:off x="6853238" y="2438402"/>
             <a:ext cx="1838325" cy="442913"/>
           </a:xfrm>
           <a:prstGeom prst="rect">
@@ -5915,7 +5915,7 @@
           <a:ln/>
         </p:spPr>
         <p:txBody>
-          <a:bodyPr wrap="square" lIns="0" tIns="0" rIns="0" bIns="0" rtlCol="0" anchor="t">
+          <a:bodyPr wrap="square" lIns="0" tIns="0" rIns="0" bIns="0" rtlCol="0" anchor="b">
             <a:normAutofit/>
           </a:bodyPr>
           <a:lstStyle/>
@@ -5951,7 +5951,7 @@
         </p:nvSpPr>
         <p:spPr>
           <a:xfrm>
-            <a:off x="6853238" y="3790950"/>
+            <a:off x="6853238" y="3733802"/>
             <a:ext cx="1838325" cy="442913"/>
           </a:xfrm>
           <a:prstGeom prst="rect">
@@ -9611,29 +9611,6 @@
           <a:chExt cx="0" cy="0"/>
         </a:xfrm>
       </p:grpSpPr>
-      <p:pic>
-        <p:nvPicPr>
-          <p:cNvPr id="2" name="Image 0" descr="preencoded.png"/>
-          <p:cNvPicPr>
-            <a:picLocks noChangeAspect="1"/>
-          </p:cNvPicPr>
-          <p:nvPr/>
-        </p:nvPicPr>
-        <p:blipFill>
-          <a:blip r:embed="rId3"/>
-          <a:srcRect/>
-          <a:stretch/>
-        </p:blipFill>
-        <p:spPr>
-          <a:xfrm>
-            <a:off x="0" y="0"/>
-            <a:ext cx="4000500" cy="5143500"/>
-          </a:xfrm>
-          <a:prstGeom prst="rect">
-            <a:avLst/>
-          </a:prstGeom>
-        </p:spPr>
-      </p:pic>
       <p:sp>
         <p:nvSpPr>
           <p:cNvPr id="3" name="Text 0"/>
@@ -9929,7 +9906,7 @@
           <p:nvPr/>
         </p:nvPicPr>
         <p:blipFill>
-          <a:blip r:embed="rId4"/>
+          <a:blip r:embed="rId3"/>
           <a:srcRect/>
           <a:stretch/>
         </p:blipFill>
@@ -9937,6 +9914,37 @@
           <a:xfrm>
             <a:off x="7324725" y="4524375"/>
             <a:ext cx="1366838" cy="285750"/>
+          </a:xfrm>
+          <a:prstGeom prst="rect">
+            <a:avLst/>
+          </a:prstGeom>
+        </p:spPr>
+      </p:pic>
+      <p:pic>
+        <p:nvPicPr>
+          <p:cNvPr id="11" name="Image 0">
+            <a:extLst>
+              <a:ext uri="{FF2B5EF4-FFF2-40B4-BE49-F238E27FC236}">
+                <a16:creationId xmlns:a16="http://schemas.microsoft.com/office/drawing/2014/main" id="{41871F62-771E-5927-BF59-E464338A6D71}"/>
+              </a:ext>
+            </a:extLst>
+          </p:cNvPr>
+          <p:cNvPicPr>
+            <a:picLocks noChangeAspect="1"/>
+          </p:cNvPicPr>
+          <p:nvPr/>
+        </p:nvPicPr>
+        <p:blipFill>
+          <a:blip r:embed="rId4"/>
+          <a:srcRect l="27561" t="158" r="28758" b="1"/>
+          <a:stretch>
+            <a:fillRect/>
+          </a:stretch>
+        </p:blipFill>
+        <p:spPr>
+          <a:xfrm>
+            <a:off x="-9525" y="1"/>
+            <a:ext cx="4000500" cy="5143499"/>
           </a:xfrm>
           <a:prstGeom prst="rect">
             <a:avLst/>
@@ -10231,7 +10239,13 @@
       </p:grpSpPr>
       <p:pic>
         <p:nvPicPr>
-          <p:cNvPr id="2" name="Image 0" descr="preencoded.png"/>
+          <p:cNvPr id="11" name="Image 0">
+            <a:extLst>
+              <a:ext uri="{FF2B5EF4-FFF2-40B4-BE49-F238E27FC236}">
+                <a16:creationId xmlns:a16="http://schemas.microsoft.com/office/drawing/2014/main" id="{346F3E1C-24A1-E0F1-E8DE-C443E5CE5E7A}"/>
+              </a:ext>
+            </a:extLst>
+          </p:cNvPr>
           <p:cNvPicPr>
             <a:picLocks noChangeAspect="1"/>
           </p:cNvPicPr>
@@ -10239,13 +10253,15 @@
         </p:nvPicPr>
         <p:blipFill>
           <a:blip r:embed="rId3"/>
-          <a:srcRect/>
-          <a:stretch/>
-        </p:blipFill>
-        <p:spPr>
-          <a:xfrm>
-            <a:off x="5143500" y="0"/>
-            <a:ext cx="4000500" cy="5143500"/>
+          <a:srcRect l="27561" t="158" r="28758" b="1"/>
+          <a:stretch>
+            <a:fillRect/>
+          </a:stretch>
+        </p:blipFill>
+        <p:spPr>
+          <a:xfrm>
+            <a:off x="5143500" y="1"/>
+            <a:ext cx="4000500" cy="5143499"/>
           </a:xfrm>
           <a:prstGeom prst="rect">
             <a:avLst/>

</xml_diff>